<commit_message>
Update food & waterr page ui
</commit_message>
<xml_diff>
--- a/Voxen.pptx
+++ b/Voxen.pptx
@@ -5,7 +5,7 @@
     <p:sldMasterId id="2147483648" r:id="rId1"/>
   </p:sldMasterIdLst>
   <p:notesMasterIdLst>
-    <p:notesMasterId r:id="rId14"/>
+    <p:notesMasterId r:id="rId13"/>
   </p:notesMasterIdLst>
   <p:sldIdLst>
     <p:sldId id="256" r:id="rId2"/>
@@ -18,8 +18,7 @@
     <p:sldId id="266" r:id="rId9"/>
     <p:sldId id="270" r:id="rId10"/>
     <p:sldId id="262" r:id="rId11"/>
-    <p:sldId id="268" r:id="rId12"/>
-    <p:sldId id="261" r:id="rId13"/>
+    <p:sldId id="261" r:id="rId12"/>
   </p:sldIdLst>
   <p:sldSz cx="9144000" cy="5143500" type="screen16x9"/>
   <p:notesSz cx="5143500" cy="9144000"/>
@@ -503,97 +502,6 @@
             <a:fld id="{F7021451-1387-4CA6-816F-3879F97B5CBC}" type="slidenum">
               <a:rPr lang="en-US"/>
               <a:t>11</a:t>
-            </a:fld>
-            <a:endParaRPr lang="en-US" dirty="0"/>
-          </a:p>
-        </p:txBody>
-      </p:sp>
-    </p:spTree>
-    <p:extLst>
-      <p:ext uri="{BB962C8B-B14F-4D97-AF65-F5344CB8AC3E}">
-        <p14:creationId xmlns:p14="http://schemas.microsoft.com/office/powerpoint/2010/main" val="3976206432"/>
-      </p:ext>
-    </p:extLst>
-  </p:cSld>
-  <p:clrMapOvr>
-    <a:masterClrMapping/>
-  </p:clrMapOvr>
-</p:notes>
-</file>
-
-<file path=ppt/notesSlides/notesSlide12.xml><?xml version="1.0" encoding="utf-8"?>
-<p:notes xmlns:a="http://schemas.openxmlformats.org/drawingml/2006/main" xmlns:r="http://schemas.openxmlformats.org/officeDocument/2006/relationships" xmlns:p="http://schemas.openxmlformats.org/presentationml/2006/main">
-  <p:cSld>
-    <p:spTree>
-      <p:nvGrpSpPr>
-        <p:cNvPr id="1" name=""/>
-        <p:cNvGrpSpPr/>
-        <p:nvPr/>
-      </p:nvGrpSpPr>
-      <p:grpSpPr>
-        <a:xfrm>
-          <a:off x="0" y="0"/>
-          <a:ext cx="0" cy="0"/>
-          <a:chOff x="0" y="0"/>
-          <a:chExt cx="0" cy="0"/>
-        </a:xfrm>
-      </p:grpSpPr>
-      <p:sp>
-        <p:nvSpPr>
-          <p:cNvPr id="2" name="Slide Image Placeholder 1"/>
-          <p:cNvSpPr>
-            <a:spLocks noGrp="1" noRot="1" noChangeAspect="1"/>
-          </p:cNvSpPr>
-          <p:nvPr>
-            <p:ph type="sldImg"/>
-          </p:nvPr>
-        </p:nvSpPr>
-        <p:spPr/>
-        <p:txBody>
-          <a:bodyPr/>
-          <a:lstStyle/>
-          <a:p>
-            <a:endParaRPr lang="en-US" dirty="0"/>
-          </a:p>
-        </p:txBody>
-      </p:sp>
-      <p:sp>
-        <p:nvSpPr>
-          <p:cNvPr id="3" name="Notes Placeholder 2"/>
-          <p:cNvSpPr>
-            <a:spLocks noGrp="1"/>
-          </p:cNvSpPr>
-          <p:nvPr>
-            <p:ph type="body" idx="1"/>
-          </p:nvPr>
-        </p:nvSpPr>
-        <p:spPr/>
-        <p:txBody>
-          <a:bodyPr/>
-          <a:lstStyle/>
-          <a:p>
-            <a:endParaRPr lang="en-US" dirty="0"/>
-          </a:p>
-        </p:txBody>
-      </p:sp>
-      <p:sp>
-        <p:nvSpPr>
-          <p:cNvPr id="4" name="Slide Number Placeholder 3"/>
-          <p:cNvSpPr>
-            <a:spLocks noGrp="1"/>
-          </p:cNvSpPr>
-          <p:nvPr>
-            <p:ph type="sldNum" sz="quarter" idx="10"/>
-          </p:nvPr>
-        </p:nvSpPr>
-        <p:spPr/>
-        <p:txBody>
-          <a:bodyPr/>
-          <a:lstStyle/>
-          <a:p>
-            <a:fld id="{F7021451-1387-4CA6-816F-3879F97B5CBC}" type="slidenum">
-              <a:rPr lang="en-US"/>
-              <a:t>12</a:t>
             </a:fld>
             <a:endParaRPr lang="en-US" dirty="0"/>
           </a:p>
@@ -2935,484 +2843,6 @@
 </file>
 
 <file path=ppt/slides/slide11.xml><?xml version="1.0" encoding="utf-8"?>
-<p:sld xmlns:a="http://schemas.openxmlformats.org/drawingml/2006/main" xmlns:r="http://schemas.openxmlformats.org/officeDocument/2006/relationships" xmlns:p="http://schemas.openxmlformats.org/presentationml/2006/main">
-  <p:cSld>
-    <p:bg>
-      <p:bgPr>
-        <a:solidFill>
-          <a:srgbClr val="080808"/>
-        </a:solidFill>
-        <a:effectLst/>
-      </p:bgPr>
-    </p:bg>
-    <p:spTree>
-      <p:nvGrpSpPr>
-        <p:cNvPr id="1" name=""/>
-        <p:cNvGrpSpPr/>
-        <p:nvPr/>
-      </p:nvGrpSpPr>
-      <p:grpSpPr>
-        <a:xfrm>
-          <a:off x="0" y="0"/>
-          <a:ext cx="0" cy="0"/>
-          <a:chOff x="0" y="0"/>
-          <a:chExt cx="0" cy="0"/>
-        </a:xfrm>
-      </p:grpSpPr>
-      <p:sp>
-        <p:nvSpPr>
-          <p:cNvPr id="28" name="Shape 17">
-            <a:extLst>
-              <a:ext uri="{FF2B5EF4-FFF2-40B4-BE49-F238E27FC236}">
-                <a16:creationId xmlns:a16="http://schemas.microsoft.com/office/drawing/2014/main" id="{C27B2D8A-E552-426C-A728-7D31B247FB9C}"/>
-              </a:ext>
-            </a:extLst>
-          </p:cNvPr>
-          <p:cNvSpPr/>
-          <p:nvPr/>
-        </p:nvSpPr>
-        <p:spPr>
-          <a:xfrm flipV="1">
-            <a:off x="291680" y="3933432"/>
-            <a:ext cx="6639840" cy="548640"/>
-          </a:xfrm>
-          <a:prstGeom prst="rect">
-            <a:avLst/>
-          </a:prstGeom>
-          <a:solidFill>
-            <a:srgbClr val="111111"/>
-          </a:solidFill>
-          <a:ln w="6350">
-            <a:solidFill>
-              <a:srgbClr val="333333"/>
-            </a:solidFill>
-            <a:prstDash val="solid"/>
-          </a:ln>
-          <a:effectLst>
-            <a:outerShdw blurRad="254000" dist="50800" dir="8100000" algn="bl" rotWithShape="0">
-              <a:srgbClr val="000000">
-                <a:alpha val="50000"/>
-              </a:srgbClr>
-            </a:outerShdw>
-          </a:effectLst>
-        </p:spPr>
-        <p:txBody>
-          <a:bodyPr/>
-          <a:lstStyle/>
-          <a:p>
-            <a:endParaRPr lang="en-US" dirty="0"/>
-          </a:p>
-        </p:txBody>
-      </p:sp>
-      <p:sp>
-        <p:nvSpPr>
-          <p:cNvPr id="2" name="Text 0"/>
-          <p:cNvSpPr/>
-          <p:nvPr/>
-        </p:nvSpPr>
-        <p:spPr>
-          <a:xfrm>
-            <a:off x="411480" y="256032"/>
-            <a:ext cx="1828800" cy="228600"/>
-          </a:xfrm>
-          <a:prstGeom prst="rect">
-            <a:avLst/>
-          </a:prstGeom>
-          <a:noFill/>
-          <a:ln/>
-        </p:spPr>
-        <p:txBody>
-          <a:bodyPr wrap="square" lIns="0" tIns="0" rIns="0" bIns="0" rtlCol="0" anchor="ctr"/>
-          <a:lstStyle/>
-          <a:p>
-            <a:pPr marL="0" indent="0">
-              <a:buNone/>
-            </a:pPr>
-            <a:r>
-              <a:rPr lang="en-US" sz="900" kern="0" spc="600" dirty="0">
-                <a:solidFill>
-                  <a:srgbClr val="AAAAAA"/>
-                </a:solidFill>
-                <a:latin typeface="Calibri" pitchFamily="34" charset="0"/>
-                <a:ea typeface="Calibri" pitchFamily="34" charset="-122"/>
-                <a:cs typeface="Calibri" pitchFamily="34" charset="-120"/>
-              </a:rPr>
-              <a:t>VOXEN</a:t>
-            </a:r>
-            <a:endParaRPr lang="en-US" sz="900" dirty="0"/>
-          </a:p>
-        </p:txBody>
-      </p:sp>
-      <p:sp>
-        <p:nvSpPr>
-          <p:cNvPr id="3" name="Text 1"/>
-          <p:cNvSpPr/>
-          <p:nvPr/>
-        </p:nvSpPr>
-        <p:spPr>
-          <a:xfrm>
-            <a:off x="457200" y="640080"/>
-            <a:ext cx="8229600" cy="548640"/>
-          </a:xfrm>
-          <a:prstGeom prst="rect">
-            <a:avLst/>
-          </a:prstGeom>
-          <a:noFill/>
-          <a:ln/>
-        </p:spPr>
-        <p:txBody>
-          <a:bodyPr wrap="square" rtlCol="0" anchor="ctr"/>
-          <a:lstStyle/>
-          <a:p>
-            <a:pPr marL="0" indent="0">
-              <a:buNone/>
-            </a:pPr>
-            <a:r>
-              <a:rPr lang="bg-BG" sz="3200" dirty="0">
-                <a:solidFill>
-                  <a:srgbClr val="FFFFFF"/>
-                </a:solidFill>
-                <a:latin typeface="Calibri Light" pitchFamily="34" charset="0"/>
-                <a:ea typeface="Calibri Light" pitchFamily="34" charset="-122"/>
-                <a:cs typeface="Calibri Light" pitchFamily="34" charset="-120"/>
-              </a:rPr>
-              <a:t>Следващи стъпки</a:t>
-            </a:r>
-            <a:endParaRPr lang="en-US" sz="3200" dirty="0"/>
-          </a:p>
-        </p:txBody>
-      </p:sp>
-      <p:sp>
-        <p:nvSpPr>
-          <p:cNvPr id="4" name="Shape 2"/>
-          <p:cNvSpPr/>
-          <p:nvPr/>
-        </p:nvSpPr>
-        <p:spPr>
-          <a:xfrm flipV="1">
-            <a:off x="372960" y="1795320"/>
-            <a:ext cx="6639840" cy="548640"/>
-          </a:xfrm>
-          <a:prstGeom prst="rect">
-            <a:avLst/>
-          </a:prstGeom>
-          <a:solidFill>
-            <a:srgbClr val="111111"/>
-          </a:solidFill>
-          <a:ln w="6350">
-            <a:solidFill>
-              <a:srgbClr val="333333"/>
-            </a:solidFill>
-            <a:prstDash val="solid"/>
-          </a:ln>
-          <a:effectLst>
-            <a:outerShdw blurRad="254000" dist="50800" dir="8100000" algn="bl" rotWithShape="0">
-              <a:srgbClr val="000000">
-                <a:alpha val="50000"/>
-              </a:srgbClr>
-            </a:outerShdw>
-          </a:effectLst>
-        </p:spPr>
-        <p:txBody>
-          <a:bodyPr/>
-          <a:lstStyle/>
-          <a:p>
-            <a:endParaRPr lang="en-US" dirty="0"/>
-          </a:p>
-        </p:txBody>
-      </p:sp>
-      <p:sp>
-        <p:nvSpPr>
-          <p:cNvPr id="6" name="Text 4"/>
-          <p:cNvSpPr/>
-          <p:nvPr/>
-        </p:nvSpPr>
-        <p:spPr>
-          <a:xfrm>
-            <a:off x="510120" y="1877616"/>
-            <a:ext cx="5902080" cy="384048"/>
-          </a:xfrm>
-          <a:prstGeom prst="rect">
-            <a:avLst/>
-          </a:prstGeom>
-          <a:noFill/>
-          <a:ln/>
-        </p:spPr>
-        <p:txBody>
-          <a:bodyPr wrap="square" lIns="0" tIns="0" rIns="0" bIns="0" rtlCol="0" anchor="ctr"/>
-          <a:lstStyle/>
-          <a:p>
-            <a:pPr marL="0" indent="0">
-              <a:buNone/>
-            </a:pPr>
-            <a:r>
-              <a:rPr lang="bg-BG" sz="1200" dirty="0">
-                <a:solidFill>
-                  <a:srgbClr val="FFFFFF"/>
-                </a:solidFill>
-                <a:latin typeface="Calibri Light" pitchFamily="34" charset="0"/>
-                <a:ea typeface="Calibri Light" pitchFamily="34" charset="-122"/>
-                <a:cs typeface="Calibri Light" pitchFamily="34" charset="-120"/>
-              </a:rPr>
-              <a:t>Интеграция със </a:t>
-            </a:r>
-            <a:r>
-              <a:rPr lang="en-US" sz="1200" dirty="0">
-                <a:solidFill>
-                  <a:srgbClr val="FFFFFF"/>
-                </a:solidFill>
-                <a:latin typeface="Calibri Light" pitchFamily="34" charset="0"/>
-                <a:ea typeface="Calibri Light" pitchFamily="34" charset="-122"/>
-                <a:cs typeface="Calibri Light" pitchFamily="34" charset="-120"/>
-              </a:rPr>
-              <a:t>Smart Home</a:t>
-            </a:r>
-            <a:endParaRPr lang="en-US" sz="1200" dirty="0"/>
-          </a:p>
-        </p:txBody>
-      </p:sp>
-      <p:sp>
-        <p:nvSpPr>
-          <p:cNvPr id="10" name="Shape 8"/>
-          <p:cNvSpPr/>
-          <p:nvPr/>
-        </p:nvSpPr>
-        <p:spPr>
-          <a:xfrm flipV="1">
-            <a:off x="372960" y="2510136"/>
-            <a:ext cx="6639840" cy="548640"/>
-          </a:xfrm>
-          <a:prstGeom prst="rect">
-            <a:avLst/>
-          </a:prstGeom>
-          <a:solidFill>
-            <a:srgbClr val="111111"/>
-          </a:solidFill>
-          <a:ln w="6350">
-            <a:solidFill>
-              <a:srgbClr val="333333"/>
-            </a:solidFill>
-            <a:prstDash val="solid"/>
-          </a:ln>
-          <a:effectLst>
-            <a:outerShdw blurRad="254000" dist="50800" dir="8100000" algn="bl" rotWithShape="0">
-              <a:srgbClr val="000000">
-                <a:alpha val="50000"/>
-              </a:srgbClr>
-            </a:outerShdw>
-          </a:effectLst>
-        </p:spPr>
-        <p:txBody>
-          <a:bodyPr/>
-          <a:lstStyle/>
-          <a:p>
-            <a:endParaRPr lang="en-US" dirty="0"/>
-          </a:p>
-        </p:txBody>
-      </p:sp>
-      <p:sp>
-        <p:nvSpPr>
-          <p:cNvPr id="12" name="Text 10"/>
-          <p:cNvSpPr/>
-          <p:nvPr/>
-        </p:nvSpPr>
-        <p:spPr>
-          <a:xfrm>
-            <a:off x="510120" y="2590416"/>
-            <a:ext cx="5902080" cy="384048"/>
-          </a:xfrm>
-          <a:prstGeom prst="rect">
-            <a:avLst/>
-          </a:prstGeom>
-          <a:noFill/>
-          <a:ln/>
-        </p:spPr>
-        <p:txBody>
-          <a:bodyPr wrap="square" lIns="0" tIns="0" rIns="0" bIns="0" rtlCol="0" anchor="ctr"/>
-          <a:lstStyle/>
-          <a:p>
-            <a:pPr marL="0" indent="0">
-              <a:buNone/>
-            </a:pPr>
-            <a:r>
-              <a:rPr lang="ru-RU" sz="1200" dirty="0">
-                <a:solidFill>
-                  <a:srgbClr val="FFFFFF"/>
-                </a:solidFill>
-                <a:latin typeface="Calibri Light" pitchFamily="34" charset="0"/>
-                <a:ea typeface="Calibri Light" pitchFamily="34" charset="-122"/>
-                <a:cs typeface="Calibri Light" pitchFamily="34" charset="-120"/>
-              </a:rPr>
-              <a:t>Повече входни методи</a:t>
-            </a:r>
-            <a:r>
-              <a:rPr lang="en-US" sz="1200" dirty="0">
-                <a:solidFill>
-                  <a:srgbClr val="FFFFFF"/>
-                </a:solidFill>
-                <a:latin typeface="Calibri Light" pitchFamily="34" charset="0"/>
-                <a:ea typeface="Calibri Light" pitchFamily="34" charset="-122"/>
-                <a:cs typeface="Calibri Light" pitchFamily="34" charset="-120"/>
-              </a:rPr>
-              <a:t> </a:t>
-            </a:r>
-            <a:r>
-              <a:rPr lang="ru-RU" sz="1200" dirty="0">
-                <a:solidFill>
-                  <a:srgbClr val="FFFFFF"/>
-                </a:solidFill>
-                <a:latin typeface="Calibri Light" pitchFamily="34" charset="0"/>
-                <a:ea typeface="Calibri Light" pitchFamily="34" charset="-122"/>
-                <a:cs typeface="Calibri Light" pitchFamily="34" charset="-120"/>
-              </a:rPr>
-              <a:t>(EMG / EEG) и предварителни настройки</a:t>
-            </a:r>
-          </a:p>
-        </p:txBody>
-      </p:sp>
-      <p:sp>
-        <p:nvSpPr>
-          <p:cNvPr id="13" name="Shape 11"/>
-          <p:cNvSpPr/>
-          <p:nvPr/>
-        </p:nvSpPr>
-        <p:spPr>
-          <a:xfrm flipV="1">
-            <a:off x="372960" y="3221784"/>
-            <a:ext cx="6639840" cy="548640"/>
-          </a:xfrm>
-          <a:prstGeom prst="rect">
-            <a:avLst/>
-          </a:prstGeom>
-          <a:solidFill>
-            <a:srgbClr val="111111"/>
-          </a:solidFill>
-          <a:ln w="6350">
-            <a:solidFill>
-              <a:srgbClr val="333333"/>
-            </a:solidFill>
-            <a:prstDash val="solid"/>
-          </a:ln>
-          <a:effectLst>
-            <a:outerShdw blurRad="254000" dist="50800" dir="8100000" algn="bl" rotWithShape="0">
-              <a:srgbClr val="000000">
-                <a:alpha val="50000"/>
-              </a:srgbClr>
-            </a:outerShdw>
-          </a:effectLst>
-        </p:spPr>
-        <p:txBody>
-          <a:bodyPr/>
-          <a:lstStyle/>
-          <a:p>
-            <a:endParaRPr lang="en-US" dirty="0"/>
-          </a:p>
-        </p:txBody>
-      </p:sp>
-      <p:sp>
-        <p:nvSpPr>
-          <p:cNvPr id="15" name="Text 13"/>
-          <p:cNvSpPr/>
-          <p:nvPr/>
-        </p:nvSpPr>
-        <p:spPr>
-          <a:xfrm>
-            <a:off x="507960" y="3308094"/>
-            <a:ext cx="5902080" cy="384048"/>
-          </a:xfrm>
-          <a:prstGeom prst="rect">
-            <a:avLst/>
-          </a:prstGeom>
-          <a:noFill/>
-          <a:ln/>
-        </p:spPr>
-        <p:txBody>
-          <a:bodyPr wrap="square" lIns="0" tIns="0" rIns="0" bIns="0" rtlCol="0" anchor="ctr"/>
-          <a:lstStyle/>
-          <a:p>
-            <a:pPr marL="0" indent="0">
-              <a:buNone/>
-            </a:pPr>
-            <a:r>
-              <a:rPr lang="bg-BG" sz="1200" dirty="0">
-                <a:solidFill>
-                  <a:srgbClr val="FFFFFF"/>
-                </a:solidFill>
-                <a:latin typeface="Calibri Light" pitchFamily="34" charset="0"/>
-                <a:ea typeface="Calibri Light" pitchFamily="34" charset="-122"/>
-                <a:cs typeface="Calibri Light" pitchFamily="34" charset="-120"/>
-              </a:rPr>
-              <a:t>Работа офлайн</a:t>
-            </a:r>
-            <a:endParaRPr lang="en-US" sz="1200" dirty="0"/>
-          </a:p>
-        </p:txBody>
-      </p:sp>
-      <p:sp>
-        <p:nvSpPr>
-          <p:cNvPr id="21" name="Text 19"/>
-          <p:cNvSpPr/>
-          <p:nvPr/>
-        </p:nvSpPr>
-        <p:spPr>
-          <a:xfrm>
-            <a:off x="507960" y="4029984"/>
-            <a:ext cx="5902080" cy="384048"/>
-          </a:xfrm>
-          <a:prstGeom prst="rect">
-            <a:avLst/>
-          </a:prstGeom>
-          <a:noFill/>
-          <a:ln/>
-        </p:spPr>
-        <p:txBody>
-          <a:bodyPr wrap="square" lIns="0" tIns="0" rIns="0" bIns="0" rtlCol="0" anchor="ctr"/>
-          <a:lstStyle/>
-          <a:p>
-            <a:pPr marL="0" indent="0">
-              <a:buNone/>
-            </a:pPr>
-            <a:r>
-              <a:rPr lang="bg-BG" sz="1200" dirty="0">
-                <a:solidFill>
-                  <a:srgbClr val="FFFFFF"/>
-                </a:solidFill>
-                <a:latin typeface="Calibri Light" pitchFamily="34" charset="0"/>
-                <a:ea typeface="Calibri Light" pitchFamily="34" charset="-122"/>
-                <a:cs typeface="Calibri Light" pitchFamily="34" charset="-120"/>
-              </a:rPr>
-              <a:t>Многоезична поддръжка</a:t>
-            </a:r>
-            <a:endParaRPr lang="en-US" sz="1200" dirty="0"/>
-          </a:p>
-        </p:txBody>
-      </p:sp>
-    </p:spTree>
-    <p:extLst>
-      <p:ext uri="{BB962C8B-B14F-4D97-AF65-F5344CB8AC3E}">
-        <p14:creationId xmlns:p14="http://schemas.microsoft.com/office/powerpoint/2010/main" val="47465724"/>
-      </p:ext>
-    </p:extLst>
-  </p:cSld>
-  <p:clrMapOvr>
-    <a:masterClrMapping/>
-  </p:clrMapOvr>
-  <mc:AlternateContent xmlns:mc="http://schemas.openxmlformats.org/markup-compatibility/2006" xmlns:p159="http://schemas.microsoft.com/office/powerpoint/2015/09/main">
-    <mc:Choice Requires="p159">
-      <p:transition xmlns:p14="http://schemas.microsoft.com/office/powerpoint/2010/main" spd="slow" p14:dur="2000">
-        <p159:morph option="byObject"/>
-      </p:transition>
-    </mc:Choice>
-    <mc:Fallback xmlns="">
-      <p:transition spd="slow">
-        <p:fade/>
-      </p:transition>
-    </mc:Fallback>
-  </mc:AlternateContent>
-</p:sld>
-</file>
-
-<file path=ppt/slides/slide12.xml><?xml version="1.0" encoding="utf-8"?>
 <p:sld xmlns:a="http://schemas.openxmlformats.org/drawingml/2006/main" xmlns:r="http://schemas.openxmlformats.org/officeDocument/2006/relationships" xmlns:p="http://schemas.openxmlformats.org/presentationml/2006/main">
   <p:cSld name="Slide 6">
     <p:bg>

</xml_diff>